<commit_message>
Fix content type in images-only deck
Co-Authored-By: Claude Sonnet 5.5 <noreply@anthropic.com>
Claude-Session: https://claude.ai/code/session_012ZsWyZaTBd6HFAkWYTTCwu
</commit_message>
<xml_diff>
--- a/deliverables/1_العرض_التقديمي/Min_Tajarib_Alhayat_ImagesOnly_NotEditable.pptx
+++ b/deliverables/1_العرض_التقديمي/Min_Tajarib_Alhayat_ImagesOnly_NotEditable.pptx
@@ -3451,7 +3451,7 @@
       </p:grpSpPr>
       <p:pic>
         <p:nvPicPr>
-          <p:cNvPr id="2" name="Image 0" descr="/tmp/claude-0/-home-user--/a6be5f54-c5fc-5152-81b5-e47355a16d24/scratchpad/out/full-01.jpg">    </p:cNvPr>
+          <p:cNvPr id="2" name="Image 0" descr="/tmp/claude-0/-home-user--/a6be5f54-c5fc-5152-81b5-e47355a16d24/scratchpad/out/full-01.jpeg">    </p:cNvPr>
           <p:cNvPicPr>
             <a:picLocks noChangeAspect="1"/>
           </p:cNvPicPr>
@@ -3500,7 +3500,7 @@
       </p:grpSpPr>
       <p:pic>
         <p:nvPicPr>
-          <p:cNvPr id="2" name="Image 0" descr="/tmp/claude-0/-home-user--/a6be5f54-c5fc-5152-81b5-e47355a16d24/scratchpad/out/full-10.jpg">    </p:cNvPr>
+          <p:cNvPr id="2" name="Image 0" descr="/tmp/claude-0/-home-user--/a6be5f54-c5fc-5152-81b5-e47355a16d24/scratchpad/out/full-10.jpeg">    </p:cNvPr>
           <p:cNvPicPr>
             <a:picLocks noChangeAspect="1"/>
           </p:cNvPicPr>
@@ -3549,7 +3549,7 @@
       </p:grpSpPr>
       <p:pic>
         <p:nvPicPr>
-          <p:cNvPr id="2" name="Image 0" descr="/tmp/claude-0/-home-user--/a6be5f54-c5fc-5152-81b5-e47355a16d24/scratchpad/out/full-11.jpg">    </p:cNvPr>
+          <p:cNvPr id="2" name="Image 0" descr="/tmp/claude-0/-home-user--/a6be5f54-c5fc-5152-81b5-e47355a16d24/scratchpad/out/full-11.jpeg">    </p:cNvPr>
           <p:cNvPicPr>
             <a:picLocks noChangeAspect="1"/>
           </p:cNvPicPr>
@@ -3598,7 +3598,7 @@
       </p:grpSpPr>
       <p:pic>
         <p:nvPicPr>
-          <p:cNvPr id="2" name="Image 0" descr="/tmp/claude-0/-home-user--/a6be5f54-c5fc-5152-81b5-e47355a16d24/scratchpad/out/full-12.jpg">    </p:cNvPr>
+          <p:cNvPr id="2" name="Image 0" descr="/tmp/claude-0/-home-user--/a6be5f54-c5fc-5152-81b5-e47355a16d24/scratchpad/out/full-12.jpeg">    </p:cNvPr>
           <p:cNvPicPr>
             <a:picLocks noChangeAspect="1"/>
           </p:cNvPicPr>
@@ -3647,7 +3647,7 @@
       </p:grpSpPr>
       <p:pic>
         <p:nvPicPr>
-          <p:cNvPr id="2" name="Image 0" descr="/tmp/claude-0/-home-user--/a6be5f54-c5fc-5152-81b5-e47355a16d24/scratchpad/out/full-13.jpg">    </p:cNvPr>
+          <p:cNvPr id="2" name="Image 0" descr="/tmp/claude-0/-home-user--/a6be5f54-c5fc-5152-81b5-e47355a16d24/scratchpad/out/full-13.jpeg">    </p:cNvPr>
           <p:cNvPicPr>
             <a:picLocks noChangeAspect="1"/>
           </p:cNvPicPr>
@@ -3696,7 +3696,7 @@
       </p:grpSpPr>
       <p:pic>
         <p:nvPicPr>
-          <p:cNvPr id="2" name="Image 0" descr="/tmp/claude-0/-home-user--/a6be5f54-c5fc-5152-81b5-e47355a16d24/scratchpad/out/full-14.jpg">    </p:cNvPr>
+          <p:cNvPr id="2" name="Image 0" descr="/tmp/claude-0/-home-user--/a6be5f54-c5fc-5152-81b5-e47355a16d24/scratchpad/out/full-14.jpeg">    </p:cNvPr>
           <p:cNvPicPr>
             <a:picLocks noChangeAspect="1"/>
           </p:cNvPicPr>
@@ -3745,7 +3745,7 @@
       </p:grpSpPr>
       <p:pic>
         <p:nvPicPr>
-          <p:cNvPr id="2" name="Image 0" descr="/tmp/claude-0/-home-user--/a6be5f54-c5fc-5152-81b5-e47355a16d24/scratchpad/out/full-15.jpg">    </p:cNvPr>
+          <p:cNvPr id="2" name="Image 0" descr="/tmp/claude-0/-home-user--/a6be5f54-c5fc-5152-81b5-e47355a16d24/scratchpad/out/full-15.jpeg">    </p:cNvPr>
           <p:cNvPicPr>
             <a:picLocks noChangeAspect="1"/>
           </p:cNvPicPr>
@@ -3794,7 +3794,7 @@
       </p:grpSpPr>
       <p:pic>
         <p:nvPicPr>
-          <p:cNvPr id="2" name="Image 0" descr="/tmp/claude-0/-home-user--/a6be5f54-c5fc-5152-81b5-e47355a16d24/scratchpad/out/full-16.jpg">    </p:cNvPr>
+          <p:cNvPr id="2" name="Image 0" descr="/tmp/claude-0/-home-user--/a6be5f54-c5fc-5152-81b5-e47355a16d24/scratchpad/out/full-16.jpeg">    </p:cNvPr>
           <p:cNvPicPr>
             <a:picLocks noChangeAspect="1"/>
           </p:cNvPicPr>
@@ -3843,7 +3843,7 @@
       </p:grpSpPr>
       <p:pic>
         <p:nvPicPr>
-          <p:cNvPr id="2" name="Image 0" descr="/tmp/claude-0/-home-user--/a6be5f54-c5fc-5152-81b5-e47355a16d24/scratchpad/out/full-17.jpg">    </p:cNvPr>
+          <p:cNvPr id="2" name="Image 0" descr="/tmp/claude-0/-home-user--/a6be5f54-c5fc-5152-81b5-e47355a16d24/scratchpad/out/full-17.jpeg">    </p:cNvPr>
           <p:cNvPicPr>
             <a:picLocks noChangeAspect="1"/>
           </p:cNvPicPr>
@@ -3892,7 +3892,7 @@
       </p:grpSpPr>
       <p:pic>
         <p:nvPicPr>
-          <p:cNvPr id="2" name="Image 0" descr="/tmp/claude-0/-home-user--/a6be5f54-c5fc-5152-81b5-e47355a16d24/scratchpad/out/full-18.jpg">    </p:cNvPr>
+          <p:cNvPr id="2" name="Image 0" descr="/tmp/claude-0/-home-user--/a6be5f54-c5fc-5152-81b5-e47355a16d24/scratchpad/out/full-18.jpeg">    </p:cNvPr>
           <p:cNvPicPr>
             <a:picLocks noChangeAspect="1"/>
           </p:cNvPicPr>
@@ -3941,7 +3941,7 @@
       </p:grpSpPr>
       <p:pic>
         <p:nvPicPr>
-          <p:cNvPr id="2" name="Image 0" descr="/tmp/claude-0/-home-user--/a6be5f54-c5fc-5152-81b5-e47355a16d24/scratchpad/out/full-19.jpg">    </p:cNvPr>
+          <p:cNvPr id="2" name="Image 0" descr="/tmp/claude-0/-home-user--/a6be5f54-c5fc-5152-81b5-e47355a16d24/scratchpad/out/full-19.jpeg">    </p:cNvPr>
           <p:cNvPicPr>
             <a:picLocks noChangeAspect="1"/>
           </p:cNvPicPr>
@@ -3990,7 +3990,7 @@
       </p:grpSpPr>
       <p:pic>
         <p:nvPicPr>
-          <p:cNvPr id="2" name="Image 0" descr="/tmp/claude-0/-home-user--/a6be5f54-c5fc-5152-81b5-e47355a16d24/scratchpad/out/full-02.jpg">    </p:cNvPr>
+          <p:cNvPr id="2" name="Image 0" descr="/tmp/claude-0/-home-user--/a6be5f54-c5fc-5152-81b5-e47355a16d24/scratchpad/out/full-02.jpeg">    </p:cNvPr>
           <p:cNvPicPr>
             <a:picLocks noChangeAspect="1"/>
           </p:cNvPicPr>
@@ -4039,7 +4039,7 @@
       </p:grpSpPr>
       <p:pic>
         <p:nvPicPr>
-          <p:cNvPr id="2" name="Image 0" descr="/tmp/claude-0/-home-user--/a6be5f54-c5fc-5152-81b5-e47355a16d24/scratchpad/out/full-20.jpg">    </p:cNvPr>
+          <p:cNvPr id="2" name="Image 0" descr="/tmp/claude-0/-home-user--/a6be5f54-c5fc-5152-81b5-e47355a16d24/scratchpad/out/full-20.jpeg">    </p:cNvPr>
           <p:cNvPicPr>
             <a:picLocks noChangeAspect="1"/>
           </p:cNvPicPr>
@@ -4088,7 +4088,7 @@
       </p:grpSpPr>
       <p:pic>
         <p:nvPicPr>
-          <p:cNvPr id="2" name="Image 0" descr="/tmp/claude-0/-home-user--/a6be5f54-c5fc-5152-81b5-e47355a16d24/scratchpad/out/full-21.jpg">    </p:cNvPr>
+          <p:cNvPr id="2" name="Image 0" descr="/tmp/claude-0/-home-user--/a6be5f54-c5fc-5152-81b5-e47355a16d24/scratchpad/out/full-21.jpeg">    </p:cNvPr>
           <p:cNvPicPr>
             <a:picLocks noChangeAspect="1"/>
           </p:cNvPicPr>
@@ -4137,7 +4137,7 @@
       </p:grpSpPr>
       <p:pic>
         <p:nvPicPr>
-          <p:cNvPr id="2" name="Image 0" descr="/tmp/claude-0/-home-user--/a6be5f54-c5fc-5152-81b5-e47355a16d24/scratchpad/out/full-22.jpg">    </p:cNvPr>
+          <p:cNvPr id="2" name="Image 0" descr="/tmp/claude-0/-home-user--/a6be5f54-c5fc-5152-81b5-e47355a16d24/scratchpad/out/full-22.jpeg">    </p:cNvPr>
           <p:cNvPicPr>
             <a:picLocks noChangeAspect="1"/>
           </p:cNvPicPr>
@@ -4186,7 +4186,7 @@
       </p:grpSpPr>
       <p:pic>
         <p:nvPicPr>
-          <p:cNvPr id="2" name="Image 0" descr="/tmp/claude-0/-home-user--/a6be5f54-c5fc-5152-81b5-e47355a16d24/scratchpad/out/full-23.jpg">    </p:cNvPr>
+          <p:cNvPr id="2" name="Image 0" descr="/tmp/claude-0/-home-user--/a6be5f54-c5fc-5152-81b5-e47355a16d24/scratchpad/out/full-23.jpeg">    </p:cNvPr>
           <p:cNvPicPr>
             <a:picLocks noChangeAspect="1"/>
           </p:cNvPicPr>
@@ -4235,7 +4235,7 @@
       </p:grpSpPr>
       <p:pic>
         <p:nvPicPr>
-          <p:cNvPr id="2" name="Image 0" descr="/tmp/claude-0/-home-user--/a6be5f54-c5fc-5152-81b5-e47355a16d24/scratchpad/out/full-24.jpg">    </p:cNvPr>
+          <p:cNvPr id="2" name="Image 0" descr="/tmp/claude-0/-home-user--/a6be5f54-c5fc-5152-81b5-e47355a16d24/scratchpad/out/full-24.jpeg">    </p:cNvPr>
           <p:cNvPicPr>
             <a:picLocks noChangeAspect="1"/>
           </p:cNvPicPr>
@@ -4284,7 +4284,7 @@
       </p:grpSpPr>
       <p:pic>
         <p:nvPicPr>
-          <p:cNvPr id="2" name="Image 0" descr="/tmp/claude-0/-home-user--/a6be5f54-c5fc-5152-81b5-e47355a16d24/scratchpad/out/full-25.jpg">    </p:cNvPr>
+          <p:cNvPr id="2" name="Image 0" descr="/tmp/claude-0/-home-user--/a6be5f54-c5fc-5152-81b5-e47355a16d24/scratchpad/out/full-25.jpeg">    </p:cNvPr>
           <p:cNvPicPr>
             <a:picLocks noChangeAspect="1"/>
           </p:cNvPicPr>
@@ -4333,7 +4333,7 @@
       </p:grpSpPr>
       <p:pic>
         <p:nvPicPr>
-          <p:cNvPr id="2" name="Image 0" descr="/tmp/claude-0/-home-user--/a6be5f54-c5fc-5152-81b5-e47355a16d24/scratchpad/out/full-26.jpg">    </p:cNvPr>
+          <p:cNvPr id="2" name="Image 0" descr="/tmp/claude-0/-home-user--/a6be5f54-c5fc-5152-81b5-e47355a16d24/scratchpad/out/full-26.jpeg">    </p:cNvPr>
           <p:cNvPicPr>
             <a:picLocks noChangeAspect="1"/>
           </p:cNvPicPr>
@@ -4382,7 +4382,7 @@
       </p:grpSpPr>
       <p:pic>
         <p:nvPicPr>
-          <p:cNvPr id="2" name="Image 0" descr="/tmp/claude-0/-home-user--/a6be5f54-c5fc-5152-81b5-e47355a16d24/scratchpad/out/full-27.jpg">    </p:cNvPr>
+          <p:cNvPr id="2" name="Image 0" descr="/tmp/claude-0/-home-user--/a6be5f54-c5fc-5152-81b5-e47355a16d24/scratchpad/out/full-27.jpeg">    </p:cNvPr>
           <p:cNvPicPr>
             <a:picLocks noChangeAspect="1"/>
           </p:cNvPicPr>
@@ -4431,7 +4431,7 @@
       </p:grpSpPr>
       <p:pic>
         <p:nvPicPr>
-          <p:cNvPr id="2" name="Image 0" descr="/tmp/claude-0/-home-user--/a6be5f54-c5fc-5152-81b5-e47355a16d24/scratchpad/out/full-28.jpg">    </p:cNvPr>
+          <p:cNvPr id="2" name="Image 0" descr="/tmp/claude-0/-home-user--/a6be5f54-c5fc-5152-81b5-e47355a16d24/scratchpad/out/full-28.jpeg">    </p:cNvPr>
           <p:cNvPicPr>
             <a:picLocks noChangeAspect="1"/>
           </p:cNvPicPr>
@@ -4480,7 +4480,7 @@
       </p:grpSpPr>
       <p:pic>
         <p:nvPicPr>
-          <p:cNvPr id="2" name="Image 0" descr="/tmp/claude-0/-home-user--/a6be5f54-c5fc-5152-81b5-e47355a16d24/scratchpad/out/full-29.jpg">    </p:cNvPr>
+          <p:cNvPr id="2" name="Image 0" descr="/tmp/claude-0/-home-user--/a6be5f54-c5fc-5152-81b5-e47355a16d24/scratchpad/out/full-29.jpeg">    </p:cNvPr>
           <p:cNvPicPr>
             <a:picLocks noChangeAspect="1"/>
           </p:cNvPicPr>
@@ -4529,7 +4529,7 @@
       </p:grpSpPr>
       <p:pic>
         <p:nvPicPr>
-          <p:cNvPr id="2" name="Image 0" descr="/tmp/claude-0/-home-user--/a6be5f54-c5fc-5152-81b5-e47355a16d24/scratchpad/out/full-03.jpg">    </p:cNvPr>
+          <p:cNvPr id="2" name="Image 0" descr="/tmp/claude-0/-home-user--/a6be5f54-c5fc-5152-81b5-e47355a16d24/scratchpad/out/full-03.jpeg">    </p:cNvPr>
           <p:cNvPicPr>
             <a:picLocks noChangeAspect="1"/>
           </p:cNvPicPr>
@@ -4578,7 +4578,7 @@
       </p:grpSpPr>
       <p:pic>
         <p:nvPicPr>
-          <p:cNvPr id="2" name="Image 0" descr="/tmp/claude-0/-home-user--/a6be5f54-c5fc-5152-81b5-e47355a16d24/scratchpad/out/full-30.jpg">    </p:cNvPr>
+          <p:cNvPr id="2" name="Image 0" descr="/tmp/claude-0/-home-user--/a6be5f54-c5fc-5152-81b5-e47355a16d24/scratchpad/out/full-30.jpeg">    </p:cNvPr>
           <p:cNvPicPr>
             <a:picLocks noChangeAspect="1"/>
           </p:cNvPicPr>
@@ -4627,7 +4627,7 @@
       </p:grpSpPr>
       <p:pic>
         <p:nvPicPr>
-          <p:cNvPr id="2" name="Image 0" descr="/tmp/claude-0/-home-user--/a6be5f54-c5fc-5152-81b5-e47355a16d24/scratchpad/out/full-04.jpg">    </p:cNvPr>
+          <p:cNvPr id="2" name="Image 0" descr="/tmp/claude-0/-home-user--/a6be5f54-c5fc-5152-81b5-e47355a16d24/scratchpad/out/full-04.jpeg">    </p:cNvPr>
           <p:cNvPicPr>
             <a:picLocks noChangeAspect="1"/>
           </p:cNvPicPr>
@@ -4676,7 +4676,7 @@
       </p:grpSpPr>
       <p:pic>
         <p:nvPicPr>
-          <p:cNvPr id="2" name="Image 0" descr="/tmp/claude-0/-home-user--/a6be5f54-c5fc-5152-81b5-e47355a16d24/scratchpad/out/full-05.jpg">    </p:cNvPr>
+          <p:cNvPr id="2" name="Image 0" descr="/tmp/claude-0/-home-user--/a6be5f54-c5fc-5152-81b5-e47355a16d24/scratchpad/out/full-05.jpeg">    </p:cNvPr>
           <p:cNvPicPr>
             <a:picLocks noChangeAspect="1"/>
           </p:cNvPicPr>
@@ -4725,7 +4725,7 @@
       </p:grpSpPr>
       <p:pic>
         <p:nvPicPr>
-          <p:cNvPr id="2" name="Image 0" descr="/tmp/claude-0/-home-user--/a6be5f54-c5fc-5152-81b5-e47355a16d24/scratchpad/out/full-06.jpg">    </p:cNvPr>
+          <p:cNvPr id="2" name="Image 0" descr="/tmp/claude-0/-home-user--/a6be5f54-c5fc-5152-81b5-e47355a16d24/scratchpad/out/full-06.jpeg">    </p:cNvPr>
           <p:cNvPicPr>
             <a:picLocks noChangeAspect="1"/>
           </p:cNvPicPr>
@@ -4774,7 +4774,7 @@
       </p:grpSpPr>
       <p:pic>
         <p:nvPicPr>
-          <p:cNvPr id="2" name="Image 0" descr="/tmp/claude-0/-home-user--/a6be5f54-c5fc-5152-81b5-e47355a16d24/scratchpad/out/full-07.jpg">    </p:cNvPr>
+          <p:cNvPr id="2" name="Image 0" descr="/tmp/claude-0/-home-user--/a6be5f54-c5fc-5152-81b5-e47355a16d24/scratchpad/out/full-07.jpeg">    </p:cNvPr>
           <p:cNvPicPr>
             <a:picLocks noChangeAspect="1"/>
           </p:cNvPicPr>
@@ -4823,7 +4823,7 @@
       </p:grpSpPr>
       <p:pic>
         <p:nvPicPr>
-          <p:cNvPr id="2" name="Image 0" descr="/tmp/claude-0/-home-user--/a6be5f54-c5fc-5152-81b5-e47355a16d24/scratchpad/out/full-08.jpg">    </p:cNvPr>
+          <p:cNvPr id="2" name="Image 0" descr="/tmp/claude-0/-home-user--/a6be5f54-c5fc-5152-81b5-e47355a16d24/scratchpad/out/full-08.jpeg">    </p:cNvPr>
           <p:cNvPicPr>
             <a:picLocks noChangeAspect="1"/>
           </p:cNvPicPr>
@@ -4872,7 +4872,7 @@
       </p:grpSpPr>
       <p:pic>
         <p:nvPicPr>
-          <p:cNvPr id="2" name="Image 0" descr="/tmp/claude-0/-home-user--/a6be5f54-c5fc-5152-81b5-e47355a16d24/scratchpad/out/full-09.jpg">    </p:cNvPr>
+          <p:cNvPr id="2" name="Image 0" descr="/tmp/claude-0/-home-user--/a6be5f54-c5fc-5152-81b5-e47355a16d24/scratchpad/out/full-09.jpeg">    </p:cNvPr>
           <p:cNvPicPr>
             <a:picLocks noChangeAspect="1"/>
           </p:cNvPicPr>

</xml_diff>